<commit_message>
USA Population Geography: 22 decks rewritten from the teacher's course support
Lessons 1-18 and Practical Works 1-4 rebuilt natively (v3n/usapop_*.js) with
definitions apart, one point per slide with its illustration, Garoua examples,
figures checked and updated (2022 milestone, densities, Cameroon rates), and
short homework preparing the next lesson. New diagrams in big_pop2.py.
Fix in gen3.js: long paragraphs split across slides no longer lose text after
a closing quote or a decimal number. Credits regenerated from the decks.

Co-Authored-By: Claude Opus 5.5 <noreply@anthropic.com>
Claude-Session: https://claude.ai/code/session_0115LFSb2ktGLWPeVksFkSer
</commit_message>
<xml_diff>
--- a/lecons/USA/Population Geography/23_USA_POP_FS01_Population_Change_in_Cameroon.pptx
+++ b/lecons/USA/Population Geography/23_USA_POP_FS01_Population_Change_in_Cameroon.pptx
@@ -3460,7 +3460,7 @@
           <a:p>
             <a:r>
               <a:rPr lang="en-US" dirty="0"/>
-              <a:t>Before we start the new lesson, let us correct the homework I gave you at the end of Lesson 18: Theories of Population and Resources: Malthus and Boserup. The question was: Write a debate: "Population growth is a problem for Cameroon." Give two arguments for and two against. Take out your exercise books.</a:t>
+              <a:t>Before we start the new lesson, let us correct the homework I gave you at the end of Lesson 18: Theories of Population and Resources: Malthus and Boserup. The question was: State the population of Cameroon at the 2005 census. Take out your exercise books.</a:t>
             </a:r>
             <a:endParaRPr lang="en-US" dirty="0"/>
           </a:p>
@@ -4340,7 +4340,7 @@
           <a:p>
             <a:r>
               <a:rPr lang="en-US" dirty="0"/>
-              <a:t>For your homework: Draw a map of Cameroon showing dense and sparse regions and the main migration flows. We shall correct it at the beginning of our next lesson.</a:t>
+              <a:t>For your homework: Define a settlement. We shall correct it at the beginning of our next lesson.</a:t>
             </a:r>
             <a:endParaRPr lang="en-US" dirty="0"/>
           </a:p>
@@ -4428,7 +4428,7 @@
           <a:p>
             <a:r>
               <a:rPr lang="en-US" dirty="0"/>
-              <a:t>Here is a good answer. For: rapid growth strains land, schools, jobs and forests (Malthus). Against: a growing population is a larger workforce and market, and pressure encourages innovation such as irrigation and terraces (Boserup). Compare it with your own answer and correct your work in red.</a:t>
+              <a:t>Here is a good answer. 17,463,836 people (about 17.5 million). Compare it with your own answer and correct your work in red.</a:t>
             </a:r>
             <a:endParaRPr lang="en-US" dirty="0"/>
           </a:p>
@@ -14980,7 +14980,7 @@
         <p:spPr>
           <a:xfrm>
             <a:off x="0" y="658368"/>
-            <a:ext cx="3840480" cy="5833872"/>
+            <a:ext cx="5120640" cy="5833872"/>
           </a:xfrm>
           <a:prstGeom prst="rect">
             <a:avLst/>
@@ -14995,8 +14995,8 @@
         </p:nvSpPr>
         <p:spPr>
           <a:xfrm>
-            <a:off x="4069080" y="1005840"/>
-            <a:ext cx="7802575" cy="731520"/>
+            <a:off x="5349240" y="1005840"/>
+            <a:ext cx="6522415" cy="731520"/>
           </a:xfrm>
           <a:prstGeom prst="rect">
             <a:avLst/>
@@ -15036,8 +15036,8 @@
         </p:nvSpPr>
         <p:spPr>
           <a:xfrm>
-            <a:off x="4069080" y="1783080"/>
-            <a:ext cx="7802575" cy="4663440"/>
+            <a:off x="5349240" y="1783080"/>
+            <a:ext cx="6522415" cy="4663440"/>
           </a:xfrm>
           <a:prstGeom prst="rect">
             <a:avLst/>
@@ -15084,7 +15084,7 @@
                 <a:ea typeface="Times New Roman" pitchFamily="34" charset="-122"/>
                 <a:cs typeface="Times New Roman" pitchFamily="34" charset="-120"/>
               </a:rPr>
-              <a:t>Write a debate: "Population growth is a problem for Cameroon." Give two arguments for and two against.</a:t>
+              <a:t>State the population of Cameroon at the 2005 census.</a:t>
             </a:r>
             <a:endParaRPr lang="en-US" sz="4000" dirty="0"/>
           </a:p>
@@ -17384,7 +17384,7 @@
                 <a:ea typeface="Times New Roman" pitchFamily="34" charset="-122"/>
                 <a:cs typeface="Times New Roman" pitchFamily="34" charset="-120"/>
               </a:rPr>
-              <a:t>Draw a map of Cameroon showing dense and sparse regions and the main migration flows.</a:t>
+              <a:t>Define a settlement.</a:t>
             </a:r>
             <a:endParaRPr lang="en-US" sz="4000" dirty="0"/>
           </a:p>
@@ -17519,7 +17519,7 @@
         <p:spPr>
           <a:xfrm>
             <a:off x="0" y="658368"/>
-            <a:ext cx="3840480" cy="5833872"/>
+            <a:ext cx="5120640" cy="5833872"/>
           </a:xfrm>
           <a:prstGeom prst="rect">
             <a:avLst/>
@@ -17534,8 +17534,8 @@
         </p:nvSpPr>
         <p:spPr>
           <a:xfrm>
-            <a:off x="4069080" y="1005840"/>
-            <a:ext cx="7802575" cy="731520"/>
+            <a:off x="5349240" y="1005840"/>
+            <a:ext cx="6522415" cy="731520"/>
           </a:xfrm>
           <a:prstGeom prst="rect">
             <a:avLst/>
@@ -17575,8 +17575,8 @@
         </p:nvSpPr>
         <p:spPr>
           <a:xfrm>
-            <a:off x="4069080" y="1783080"/>
-            <a:ext cx="7802575" cy="4663440"/>
+            <a:off x="5349240" y="1783080"/>
+            <a:ext cx="6522415" cy="4663440"/>
           </a:xfrm>
           <a:prstGeom prst="rect">
             <a:avLst/>
@@ -17603,7 +17603,7 @@
                 <a:ea typeface="Times New Roman" pitchFamily="34" charset="-122"/>
                 <a:cs typeface="Times New Roman" pitchFamily="34" charset="-120"/>
               </a:rPr>
-              <a:t>For: rapid growth strains land, schools, jobs and forests (Malthus). Against: a growing population is a larger workforce and market, and pressure encourages innovation such as irrigation and terraces (Boserup).</a:t>
+              <a:t>17,463,836 people (about 17.5 million).</a:t>
             </a:r>
             <a:endParaRPr lang="en-US" sz="4000" dirty="0"/>
           </a:p>
@@ -20267,7 +20267,7 @@
                           <a:ea typeface="Calibri" pitchFamily="34" charset="-122"/>
                           <a:cs typeface="Calibri" pitchFamily="34" charset="-120"/>
                         </a:rPr>
-                        <a:t>Draw a map of Cameroon showing dense and sparse regions and the main migration flows.</a:t>
+                        <a:t>Define a settlement.</a:t>
                       </a:r>
                       <a:endParaRPr lang="en-US" sz="1600" dirty="0">
                         <a:latin typeface="Calibri" charset="0"/>

</xml_diff>